<commit_message>
Update decks to the live-LLM story (record-replay), with a LIVE capture
The decks still claimed "cached LLM · the only LLM · 100% offline"; the LLM now
runs live. Both themes (PPTX+PDF, 11 slides) rebuilt:

- Slide 7B: two live proofs side by side — the validation gate rejecting
  fabrications, and a real capture of an APPROVED card narrated by NVIDIA
  Llama-3.3-70B with the LIVE ✦ · recorded-for-replay chip. New callout:
  "A live model makes the call. The record replays byte-identically. A human
  signs."
- Slide 7: PROPOSER box cached-LLM → LIVE LLM; caption + right-tool row now say
  live at the edges via a key-holding worker, recorded for replay, cache as the
  airplane-mode fallback.
- Slides 3/5: "100% offline" / "cached at build time" softened to the same
  live-at-the-edges + deterministic-core framing.
- docs/TRINETRA-deck.md spec updated to match (7B visuals + speaker note,
  slide-7 diagram).

Co-Authored-By: Claude Opus 4.8 <noreply@anthropic.com>
</commit_message>
<xml_diff>
--- a/TRINETRA_Deck_Light.pptx
+++ b/TRINETRA_Deck_Light.pptx
@@ -5383,7 +5383,7 @@
                 <a:ea typeface="Helvetica Neue" pitchFamily="34" charset="-122"/>
                 <a:cs typeface="Helvetica Neue" pitchFamily="34" charset="-120"/>
               </a:rPr>
-              <a:t>One screen, one engine: signals → exposure-graph re-score → machine-generated option cards → charter debate → hash-chained audit. 100% offline.</a:t>
+              <a:t>One screen, one engine: signals → exposure-graph re-score → machine-generated option cards → charter debate → hash-chained audit. Live LLM at the edges; deterministic core runs offline.</a:t>
             </a:r>
             <a:endParaRPr lang="en-US" sz="850" dirty="0"/>
           </a:p>
@@ -7150,7 +7150,7 @@
                 <a:ea typeface="Helvetica Neue" pitchFamily="34" charset="-122"/>
                 <a:cs typeface="Helvetica Neue" pitchFamily="34" charset="-120"/>
               </a:rPr>
-              <a:t>LLM text is cached at build time — the demo runs in airplane mode. Per-refinery inventories are modeled (S), and we say so.</a:t>
+              <a:t>The LLM runs LIVE (NVIDIA, via a key-holding edge worker) and every completion is recorded for replay; airplane mode falls back to the build-time cache. Per-refinery inventories are modeled (S), and we say so.</a:t>
             </a:r>
             <a:endParaRPr lang="en-US" sz="1050" dirty="0"/>
           </a:p>
@@ -8585,7 +8585,7 @@
                 <a:ea typeface="Helvetica Neue" pitchFamily="34" charset="-122"/>
                 <a:cs typeface="Helvetica Neue" pitchFamily="34" charset="-120"/>
               </a:rPr>
-              <a:t>cached LLM</a:t>
+              <a:t>LIVE LLM</a:t>
             </a:r>
             <a:endParaRPr lang="en-US" sz="900" dirty="0"/>
           </a:p>
@@ -9005,7 +9005,7 @@
                 <a:ea typeface="Helvetica Neue" pitchFamily="34" charset="-122"/>
                 <a:cs typeface="Helvetica Neue" pitchFamily="34" charset="-120"/>
               </a:rPr>
-              <a:t>solid = deterministic       proposer text is cached at build time (the only LLM)</a:t>
+              <a:t>solid = deterministic   ·   proposer prose is LIVE (NVIDIA via a key-holding edge worker), recorded for replay; cache is the airplane-mode fallback</a:t>
             </a:r>
             <a:endParaRPr lang="en-US" sz="1000" dirty="0"/>
           </a:p>
@@ -9530,7 +9530,7 @@
                 <a:ea typeface="Helvetica Neue" pitchFamily="34" charset="-122"/>
                 <a:cs typeface="Helvetica Neue" pitchFamily="34" charset="-120"/>
               </a:rPr>
-              <a:t>cached offline; only prose may vary</a:t>
+              <a:t>live at the edges, recorded for replay — only prose may vary</a:t>
             </a:r>
             <a:endParaRPr lang="en-US" sz="1200" dirty="0"/>
           </a:p>
@@ -10718,7 +10718,7 @@
         <p:spPr>
           <a:xfrm>
             <a:off x="502920" y="3246120"/>
-            <a:ext cx="11155680" cy="274320"/>
+            <a:ext cx="7223760" cy="274320"/>
           </a:xfrm>
           <a:prstGeom prst="rect">
             <a:avLst/>
@@ -10742,7 +10742,7 @@
                 <a:ea typeface="Helvetica Neue" pitchFamily="34" charset="-122"/>
                 <a:cs typeface="Helvetica Neue" pitchFamily="34" charset="-120"/>
               </a:rPr>
-              <a:t>THE GATE, LIVE — a hallucinated Brent 9000, a 200-day floor, a made-up grade, all rejected before scoring:</a:t>
+              <a:t>THE GATE, LIVE — a hallucinated Brent 9000 and a made-up grade, rejected before scoring:</a:t>
             </a:r>
             <a:endParaRPr lang="en-US" sz="1100" dirty="0"/>
           </a:p>
@@ -10750,14 +10750,53 @@
       </p:sp>
       <p:sp>
         <p:nvSpPr>
-          <p:cNvPr id="38" name="Shape 36"/>
+          <p:cNvPr id="38" name="Text 36"/>
+          <p:cNvSpPr/>
+          <p:nvPr/>
+        </p:nvSpPr>
+        <p:spPr>
+          <a:xfrm>
+            <a:off x="7909560" y="3246120"/>
+            <a:ext cx="3749040" cy="274320"/>
+          </a:xfrm>
+          <a:prstGeom prst="rect">
+            <a:avLst/>
+          </a:prstGeom>
+          <a:noFill/>
+          <a:ln/>
+        </p:spPr>
+        <p:txBody>
+          <a:bodyPr wrap="square" lIns="0" tIns="0" rIns="0" bIns="0" rtlCol="0" anchor="t"/>
+          <a:lstStyle/>
+          <a:p>
+            <a:pPr algn="l" indent="0" marL="0">
+              <a:buNone/>
+            </a:pPr>
+            <a:r>
+              <a:rPr lang="en-US" sz="1100" b="1" spc="50" kern="0" dirty="0">
+                <a:solidFill>
+                  <a:srgbClr val="1E8E56"/>
+                </a:solidFill>
+                <a:latin typeface="Helvetica Neue" pitchFamily="34" charset="0"/>
+                <a:ea typeface="Helvetica Neue" pitchFamily="34" charset="-122"/>
+                <a:cs typeface="Helvetica Neue" pitchFamily="34" charset="-120"/>
+              </a:rPr>
+              <a:t>THE MODEL, LIVE ✦ — NVIDIA, on every update:</a:t>
+            </a:r>
+            <a:endParaRPr lang="en-US" sz="1100" dirty="0"/>
+          </a:p>
+        </p:txBody>
+      </p:sp>
+      <p:sp>
+        <p:nvSpPr>
+          <p:cNvPr id="39" name="Shape 37"/>
           <p:cNvSpPr/>
           <p:nvPr/>
         </p:nvSpPr>
         <p:spPr>
           <a:xfrm>
             <a:off x="502920" y="3566160"/>
-            <a:ext cx="11155680" cy="1373522"/>
+            <a:ext cx="7223760" cy="889412"/>
           </a:xfrm>
           <a:prstGeom prst="rect">
             <a:avLst/>
@@ -10777,7 +10816,7 @@
       </p:sp>
       <p:pic>
         <p:nvPicPr>
-          <p:cNvPr id="39" name="Image 0" descr="/private/tmp/claude-501/-Users-aman-Downloads-ET-Hackathon/ab60fbe1-6f03-48e5-aa7b-8b187ce1082a/scratchpad/deck-assets/ai_gate.png">    </p:cNvPr>
+          <p:cNvPr id="40" name="Image 0" descr="/private/tmp/claude-501/-Users-aman-Downloads-ET-Hackathon/ab60fbe1-6f03-48e5-aa7b-8b187ce1082a/scratchpad/deck-assets/ai_gate.png">    </p:cNvPr>
           <p:cNvPicPr>
             <a:picLocks noChangeAspect="1"/>
           </p:cNvPicPr>
@@ -10792,7 +10831,7 @@
         <p:spPr>
           <a:xfrm>
             <a:off x="502920" y="3566160"/>
-            <a:ext cx="11155680" cy="1373522"/>
+            <a:ext cx="7223760" cy="889412"/>
           </a:xfrm>
           <a:prstGeom prst="rect">
             <a:avLst/>
@@ -10801,14 +10840,14 @@
       </p:pic>
       <p:sp>
         <p:nvSpPr>
-          <p:cNvPr id="40" name="Shape 37"/>
+          <p:cNvPr id="41" name="Shape 38"/>
           <p:cNvSpPr/>
           <p:nvPr/>
         </p:nvSpPr>
         <p:spPr>
           <a:xfrm>
             <a:off x="502920" y="3566160"/>
-            <a:ext cx="11155680" cy="1373522"/>
+            <a:ext cx="7223760" cy="889412"/>
           </a:xfrm>
           <a:prstGeom prst="rect">
             <a:avLst/>
@@ -10823,13 +10862,125 @@
       </p:sp>
       <p:sp>
         <p:nvSpPr>
-          <p:cNvPr id="41" name="Shape 38"/>
-          <p:cNvSpPr/>
-          <p:nvPr/>
-        </p:nvSpPr>
-        <p:spPr>
-          <a:xfrm>
-            <a:off x="502920" y="5122562"/>
+          <p:cNvPr id="42" name="Shape 39"/>
+          <p:cNvSpPr/>
+          <p:nvPr/>
+        </p:nvSpPr>
+        <p:spPr>
+          <a:xfrm>
+            <a:off x="7909560" y="3566160"/>
+            <a:ext cx="3749040" cy="1051391"/>
+          </a:xfrm>
+          <a:prstGeom prst="rect">
+            <a:avLst/>
+          </a:prstGeom>
+          <a:solidFill>
+            <a:srgbClr val="FFFFFF"/>
+          </a:solidFill>
+          <a:ln/>
+          <a:effectLst>
+            <a:outerShdw sx="100000" sy="100000" kx="0" ky="0" algn="bl" rotWithShape="0" blurRad="114300" dist="38100" dir="8100000">
+              <a:srgbClr val="7A7266">
+                <a:alpha val="28000"/>
+              </a:srgbClr>
+            </a:outerShdw>
+          </a:effectLst>
+        </p:spPr>
+      </p:sp>
+      <p:pic>
+        <p:nvPicPr>
+          <p:cNvPr id="43" name="Image 1" descr="/private/tmp/claude-501/-Users-aman-Downloads-ET-Hackathon/ab60fbe1-6f03-48e5-aa7b-8b187ce1082a/scratchpad/deck-assets/live_card.png">    </p:cNvPr>
+          <p:cNvPicPr>
+            <a:picLocks noChangeAspect="1"/>
+          </p:cNvPicPr>
+          <p:nvPr/>
+        </p:nvPicPr>
+        <p:blipFill>
+          <a:blip r:embed="rId2"/>
+          <a:stretch>
+            <a:fillRect/>
+          </a:stretch>
+        </p:blipFill>
+        <p:spPr>
+          <a:xfrm>
+            <a:off x="7909560" y="3566160"/>
+            <a:ext cx="3749040" cy="1051391"/>
+          </a:xfrm>
+          <a:prstGeom prst="rect">
+            <a:avLst/>
+          </a:prstGeom>
+        </p:spPr>
+      </p:pic>
+      <p:sp>
+        <p:nvSpPr>
+          <p:cNvPr id="44" name="Shape 40"/>
+          <p:cNvSpPr/>
+          <p:nvPr/>
+        </p:nvSpPr>
+        <p:spPr>
+          <a:xfrm>
+            <a:off x="7909560" y="3566160"/>
+            <a:ext cx="3749040" cy="1051391"/>
+          </a:xfrm>
+          <a:prstGeom prst="rect">
+            <a:avLst/>
+          </a:prstGeom>
+          <a:ln w="19050">
+            <a:solidFill>
+              <a:srgbClr val="1E8E56"/>
+            </a:solidFill>
+            <a:prstDash val="solid"/>
+          </a:ln>
+        </p:spPr>
+      </p:sp>
+      <p:sp>
+        <p:nvSpPr>
+          <p:cNvPr id="45" name="Text 41"/>
+          <p:cNvSpPr/>
+          <p:nvPr/>
+        </p:nvSpPr>
+        <p:spPr>
+          <a:xfrm>
+            <a:off x="7909560" y="4663271"/>
+            <a:ext cx="3749040" cy="256032"/>
+          </a:xfrm>
+          <a:prstGeom prst="rect">
+            <a:avLst/>
+          </a:prstGeom>
+          <a:noFill/>
+          <a:ln/>
+        </p:spPr>
+        <p:txBody>
+          <a:bodyPr wrap="square" lIns="0" tIns="0" rIns="0" bIns="0" rtlCol="0" anchor="t"/>
+          <a:lstStyle/>
+          <a:p>
+            <a:pPr algn="l" indent="0" marL="0">
+              <a:buNone/>
+            </a:pPr>
+            <a:r>
+              <a:rPr lang="en-US" sz="900" i="1" dirty="0">
+                <a:solidFill>
+                  <a:srgbClr val="6C7480"/>
+                </a:solidFill>
+                <a:latin typeface="Helvetica Neue" pitchFamily="34" charset="0"/>
+                <a:ea typeface="Helvetica Neue" pitchFamily="34" charset="-122"/>
+                <a:cs typeface="Helvetica Neue" pitchFamily="34" charset="-120"/>
+              </a:rPr>
+              <a:t>live Llama-3.3-70B rationale, recorded for replay — captured from the app</a:t>
+            </a:r>
+            <a:endParaRPr lang="en-US" sz="900" dirty="0"/>
+          </a:p>
+        </p:txBody>
+      </p:sp>
+      <p:sp>
+        <p:nvSpPr>
+          <p:cNvPr id="46" name="Shape 42"/>
+          <p:cNvSpPr/>
+          <p:nvPr/>
+        </p:nvSpPr>
+        <p:spPr>
+          <a:xfrm>
+            <a:off x="502920" y="4965023"/>
             <a:ext cx="11155680" cy="1170432"/>
           </a:xfrm>
           <a:prstGeom prst="rect">
@@ -10848,13 +10999,13 @@
       </p:sp>
       <p:sp>
         <p:nvSpPr>
-          <p:cNvPr id="42" name="Shape 39"/>
-          <p:cNvSpPr/>
-          <p:nvPr/>
-        </p:nvSpPr>
-        <p:spPr>
-          <a:xfrm>
-            <a:off x="502920" y="5122562"/>
+          <p:cNvPr id="47" name="Shape 43"/>
+          <p:cNvSpPr/>
+          <p:nvPr/>
+        </p:nvSpPr>
+        <p:spPr>
+          <a:xfrm>
+            <a:off x="502920" y="4965023"/>
             <a:ext cx="64008" cy="1170432"/>
           </a:xfrm>
           <a:prstGeom prst="rect">
@@ -10868,13 +11019,13 @@
       </p:sp>
       <p:sp>
         <p:nvSpPr>
-          <p:cNvPr id="43" name="Text 40"/>
-          <p:cNvSpPr/>
-          <p:nvPr/>
-        </p:nvSpPr>
-        <p:spPr>
-          <a:xfrm>
-            <a:off x="777240" y="5250578"/>
+          <p:cNvPr id="48" name="Text 44"/>
+          <p:cNvSpPr/>
+          <p:nvPr/>
+        </p:nvSpPr>
+        <p:spPr>
+          <a:xfrm>
+            <a:off x="777240" y="5093039"/>
             <a:ext cx="10698480" cy="365760"/>
           </a:xfrm>
           <a:prstGeom prst="rect">
@@ -10899,7 +11050,7 @@
                 <a:ea typeface="Helvetica Neue" pitchFamily="34" charset="-122"/>
                 <a:cs typeface="Helvetica Neue" pitchFamily="34" charset="-120"/>
               </a:rPr>
-              <a:t>AI for sense-making and constitutional auditing.  Deterministic logic for scoring.  Humans for final approval.</a:t>
+              <a:t>A live model makes the call. The record replays byte-identically. A human signs.</a:t>
             </a:r>
             <a:endParaRPr lang="en-US" sz="1500" dirty="0"/>
           </a:p>
@@ -10907,13 +11058,13 @@
       </p:sp>
       <p:sp>
         <p:nvSpPr>
-          <p:cNvPr id="44" name="Text 41"/>
-          <p:cNvSpPr/>
-          <p:nvPr/>
-        </p:nvSpPr>
-        <p:spPr>
-          <a:xfrm>
-            <a:off x="777240" y="5625482"/>
+          <p:cNvPr id="49" name="Text 45"/>
+          <p:cNvSpPr/>
+          <p:nvPr/>
+        </p:nvSpPr>
+        <p:spPr>
+          <a:xfrm>
+            <a:off x="777240" y="5467943"/>
             <a:ext cx="10698480" cy="621792"/>
           </a:xfrm>
           <a:prstGeom prst="rect">
@@ -10941,7 +11092,7 @@
                 <a:ea typeface="Helvetica Neue" pitchFamily="34" charset="-122"/>
                 <a:cs typeface="Helvetica Neue" pitchFamily="34" charset="-120"/>
               </a:rPr>
-              <a:t>Extraction, every gate rejection, scoring, the AI audit, and the human sign-off are each appended to the same SHA-256 hash chain — byte-identical on replay, offline. The LLM is asked for strict JSON and told never to score; anything it fabricates is dropped with a reason and never reaches the engine.</a:t>
+              <a:t>The LLM runs LIVE on every decision-state change — NVIDIA Llama-3.3-70B through a key-holding Cloudflare Worker; the browser never sees a key. Every completion is RECORDED and replays byte-identically; the validation gate still drops anything fabricated before it can touch a score; scoring stays deterministic and offline-checkable.</a:t>
             </a:r>
             <a:endParaRPr lang="en-US" sz="1150" dirty="0"/>
           </a:p>
@@ -10949,7 +11100,7 @@
       </p:sp>
       <p:sp>
         <p:nvSpPr>
-          <p:cNvPr id="45" name="Text 42"/>
+          <p:cNvPr id="50" name="Text 46"/>
           <p:cNvSpPr/>
           <p:nvPr/>
         </p:nvSpPr>
@@ -10980,7 +11131,7 @@
                 <a:ea typeface="Helvetica Neue" pitchFamily="34" charset="-122"/>
                 <a:cs typeface="Helvetica Neue" pitchFamily="34" charset="-120"/>
               </a:rPr>
-              <a:t>Given the validated facts, scoring and its audit hashes are byte-identical — the guardrail is what makes an LLM safe for intake. Try it: AI ASSIST ✦ → “⚠ Hallucination test.”</a:t>
+              <a:t>AI for sense-making and auditing · deterministic logic for scoring · humans for approval. Try it live: AI ASSIST ✦ → “⚠ Hallucination test.”</a:t>
             </a:r>
             <a:endParaRPr lang="en-US" sz="850" dirty="0"/>
           </a:p>

</xml_diff>

<commit_message>
Rebuild deck: slide 1 now honest about the live LLM (no "offline" overclaim)
Slide 1 predated the live-LLM-by-default switch (2026-07-19) and still claimed
"Every step hash-chained, byte-identical, offline" + a "100% client-side, offline"
footer — which contradicts the live NVIDIA call now made on every decision-state
change. Corrected to the record-replay framing:
  subtitle → "A live model makes the call; the record replays byte-identically."
  footer   → "live NVIDIA LLM at the edges"
The PROPOSE/ENFORCE/RECORD trio stays accurate — RECORD's "hash-chained, offline"
describes the audit chain (the live model is in PROPOSE). Both themes + PDFs rebuilt.

Co-Authored-By: Claude Opus 4.8 <noreply@anthropic.com>
</commit_message>
<xml_diff>
--- a/TRINETRA_Deck_Light.pptx
+++ b/TRINETRA_Deck_Light.pptx
@@ -1966,7 +1966,7 @@
                 <a:ea typeface="Helvetica Neue" pitchFamily="34" charset="-122"/>
                 <a:cs typeface="Helvetica Neue" pitchFamily="34" charset="-120"/>
               </a:rPr>
-              <a:t>AI for sense-making and constitutional auditing · deterministic logic for scoring · humans for final approval. Every step hash-chained, byte-identical, offline.</a:t>
+              <a:t>AI for sense-making and constitutional auditing · deterministic logic for scoring · humans for final approval. A live model makes the call; the record replays byte-identically.</a:t>
             </a:r>
             <a:endParaRPr lang="en-US" sz="1400" dirty="0"/>
           </a:p>
@@ -2594,7 +2594,7 @@
                 <a:ea typeface="Helvetica Neue" pitchFamily="34" charset="-122"/>
                 <a:cs typeface="Helvetica Neue" pitchFamily="34" charset="-120"/>
               </a:rPr>
-              <a:t>ET AI Hackathon 2026  ·  100% client-side, offline  ·  deterministic, byte-identical replay  ·  zero-LLM critic  ·  live on-screen decision clock</a:t>
+              <a:t>ET AI Hackathon 2026  ·  live NVIDIA LLM at the edges  ·  deterministic, byte-identical replay  ·  zero-LLM critic  ·  live on-screen decision clock</a:t>
             </a:r>
             <a:endParaRPr lang="en-US" sz="850" dirty="0"/>
           </a:p>

</xml_diff>